<commit_message>
Forecasting: simpler code without loops; updated deck
Co-Authored-By: Claude Opus 5.5 <noreply@anthropic.com>
Claude-Session: https://claude.ai/code/session_01TbrdxHn7W6FVXXnpqzNytd
</commit_message>
<xml_diff>
--- a/slides/forecasting-and-time-series_WT26-27.pptx
+++ b/slides/forecasting-and-time-series_WT26-27.pptx
@@ -2664,7 +2664,7 @@
           <a:lstStyle/>
           <a:p>
             <a:r>
-              <a:t>The column t counts the months 1 to 120, and C(m) turns the month number into 11 dummies with January as the baseline, as for the quarters of the chocolate shop (slide 16). The model is fitted on the first 96 rows and predicts the last 24 on the log scale; np.exp() brings the forecast back. The loop computes the three measures of slide 19 for every method. The qmd prints the full table with great_tables and adds ETS (Step 7), the 2019 bands (Step 8) and the residual check (Step 9).</a:t>
+              <a:t>The column t counts the months 1 to 120, and C(m) turns the month number into 11 dummies with January as the baseline, as for the quarters of the chocolate shop (slide 16). The model is fitted on the first 96 rows and predicts the last 24 on the log scale; np.exp() brings the forecast back. pl.DataFrame(fc) puts the forecasts side by side, one column per method, and pl.all() means every column, so each line computes one measure of slide 19 for all methods at once, without a loop: a holds the absolute errors and a.mean() is the MAE; RMSE squares them, MAPE divides them by the actual. The three rows of the result are MAE, RMSE and MAPE. The qmd prints the full table with great_tables and adds ETS (Step 7), the 2019 bands (Step 8) and the residual check (Step 9).</a:t>
             </a:r>
           </a:p>
         </p:txBody>
@@ -36700,7 +36700,7 @@
                     <a:p>
                       <a:r>
                         <a:rPr sz="1150" lang="en-GB"/>
-                        <a:t>numpy, great_tables</a:t>
+                        <a:t>polars, great_tables</a:t>
                       </a:r>
                     </a:p>
                   </a:txBody>
@@ -36715,7 +36715,7 @@
                         <a:rPr sz="1150" lang="en-GB">
                           <a:latin typeface="Consolas"/>
                         </a:rPr>
-                        <a:t>np.mean(np.abs(e)); GT()</a:t>
+                        <a:t>select(pl.all()); mean(); GT()</a:t>
                       </a:r>
                     </a:p>
                   </a:txBody>
@@ -40730,7 +40730,7 @@
                   <a:schemeClr val="bg1"/>
                 </a:solidFill>
               </a:rPr>
-              <a:t>Python: statsmodels, numpy</a:t>
+              <a:t>Python: statsmodels, polars</a:t>
             </a:r>
           </a:p>
         </p:txBody>
@@ -40955,7 +40955,7 @@
                 </a:solidFill>
                 <a:latin typeface="Consolas"/>
               </a:rPr>
-              <a:t>for k, f in fc.items():</a:t>
+              <a:t>f = pl.DataFrame(fc)  # a column per method</a:t>
             </a:r>
           </a:p>
           <a:p>
@@ -40971,7 +40971,7 @@
                 </a:solidFill>
                 <a:latin typeface="Consolas"/>
               </a:rPr>
-              <a:t>    e = test - np.asarray(f)</a:t>
+              <a:t>a = f.select((pl.all() - test).abs())</a:t>
             </a:r>
           </a:p>
           <a:p>
@@ -40987,7 +40987,7 @@
                 </a:solidFill>
                 <a:latin typeface="Consolas"/>
               </a:rPr>
-              <a:t>    mae = np.mean(np.abs(e))</a:t>
+              <a:t>rmse = a.select((pl.all() ** 2).mean().sqrt())</a:t>
             </a:r>
           </a:p>
           <a:p>
@@ -41003,7 +41003,7 @@
                 </a:solidFill>
                 <a:latin typeface="Consolas"/>
               </a:rPr>
-              <a:t>    rmse = np.sqrt(np.mean(e ** 2))</a:t>
+              <a:t>mape = a.select(pl.all() / test).mean() * 100</a:t>
             </a:r>
           </a:p>
           <a:p>
@@ -41019,7 +41019,7 @@
                 </a:solidFill>
                 <a:latin typeface="Consolas"/>
               </a:rPr>
-              <a:t>    mape = 100 * np.mean(np.abs(e) / test)</a:t>
+              <a:t>acc = pl.concat([a.mean(), rmse, mape])</a:t>
             </a:r>
           </a:p>
           <a:p>
@@ -41035,23 +41035,7 @@
                 </a:solidFill>
                 <a:latin typeface="Consolas"/>
               </a:rPr>
-              <a:t>    print(k, round(mae, 1), round(rmse, 1),</a:t>
-            </a:r>
-          </a:p>
-          <a:p>
-            <a:pPr algn="l">
-              <a:spcAft>
-                <a:spcPts val="0"/>
-              </a:spcAft>
-            </a:pPr>
-            <a:r>
-              <a:rPr sz="1000" b="0" lang="en-GB">
-                <a:solidFill>
-                  <a:schemeClr val="bg1"/>
-                </a:solidFill>
-                <a:latin typeface="Consolas"/>
-              </a:rPr>
-              <a:t>          round(mape, 1))</a:t>
+              <a:t>acc.select(pl.all().round(1))  # MAE RMSE MAPE</a:t>
             </a:r>
           </a:p>
         </p:txBody>

</xml_diff>